<commit_message>
docs: lengthen talk decks and add logo
</commit_message>
<xml_diff>
--- a/docs/talk.pptx
+++ b/docs/talk.pptx
@@ -165,14 +165,14 @@
   <p:extLst>
     <p:ext uri="{521415D9-36F7-43E2-AB2F-B90AF26B5E84}">
       <p14:sectionLst xmlns:p14="http://schemas.microsoft.com/office/powerpoint/2010/main">
-        <p14:section name="Intro" id="{6df75ba0-29ab-0e4c-d51b-1a9d5e0f8769}">
+        <p14:section name="Intro" id="{a378ecd6-e0db-322b-2b53-9511faa17f13}">
           <p14:sldIdLst>
             <p14:sldId id="256"/>
             <p14:sldId id="257"/>
             <p14:sldId id="258"/>
           </p14:sldIdLst>
         </p14:section>
-        <p14:section name="Parity" id="{78865b51-d8eb-ec35-67ff-991d12c2954e}">
+        <p14:section name="Parity" id="{fb4a0ac4-4df9-3022-e8db-7afa154e1f4c}">
           <p14:sldIdLst>
             <p14:sldId id="259"/>
             <p14:sldId id="260"/>
@@ -180,14 +180,14 @@
             <p14:sldId id="262"/>
           </p14:sldIdLst>
         </p14:section>
-        <p14:section name="Engine" id="{12daa743-2a9c-aa25-e585-7f0f2f37029f}">
+        <p14:section name="Engine" id="{6cc9dad6-02c5-1ee4-b471-b7e120ba0a6d}">
           <p14:sldIdLst>
             <p14:sldId id="263"/>
             <p14:sldId id="264"/>
             <p14:sldId id="265"/>
           </p14:sldIdLst>
         </p14:section>
-        <p14:section name="Outline" id="{d6c5ecc8-e9c9-1786-0f32-9c513c7b9c6f}">
+        <p14:section name="Outline" id="{765f63b3-a5c3-4bbb-9e56-6c5d7b8960f1}">
           <p14:sldIdLst>
             <p14:sldId id="266"/>
             <p14:sldId id="273"/>
@@ -200,7 +200,7 @@
             <p14:sldId id="302"/>
           </p14:sldIdLst>
         </p14:section>
-        <p14:section name="Execution" id="{41434308-6046-488e-5971-84753ce92d4d}">
+        <p14:section name="Execution" id="{a4c63156-76fa-36ae-3142-0972b1fd708f}">
           <p14:sldIdLst>
             <p14:sldId id="267"/>
             <p14:sldId id="268"/>
@@ -210,7 +210,7 @@
             <p14:sldId id="272"/>
           </p14:sldIdLst>
         </p14:section>
-        <p14:section name="State" id="{127f07fa-4df6-3c1f-86eb-8f331c22fa70}">
+        <p14:section name="State" id="{05cbe74b-b764-0720-59d3-2b8ded686cfa}">
           <p14:sldIdLst>
             <p14:sldId id="274"/>
             <p14:sldId id="275"/>
@@ -219,7 +219,7 @@
             <p14:sldId id="278"/>
           </p14:sldIdLst>
         </p14:section>
-        <p14:section name="Line editor and prompt" id="{f29ee639-cee9-4d3d-c6f9-7d2c685e9d57}">
+        <p14:section name="Line editor and prompt" id="{041f5a78-f88e-d459-bb03-a29f47bd56a9}">
           <p14:sldIdLst>
             <p14:sldId id="280"/>
             <p14:sldId id="281"/>
@@ -229,38 +229,38 @@
             <p14:sldId id="285"/>
           </p14:sldIdLst>
         </p14:section>
-        <p14:section name="Observability" id="{89b9f99b-6d98-9318-345c-a8f9808396d1}">
+        <p14:section name="Observability" id="{ea31ea71-449c-378d-98a2-9b00e9643bf6}">
           <p14:sldIdLst>
             <p14:sldId id="287"/>
             <p14:sldId id="288"/>
             <p14:sldId id="289"/>
           </p14:sldIdLst>
         </p14:section>
-        <p14:section name="Language" id="{e0fd9a16-1344-fe13-756f-307a5c12a171}">
+        <p14:section name="Language" id="{5c5ca2b3-dfdf-64ee-e069-fc6b63879574}">
           <p14:sldIdLst>
             <p14:sldId id="291"/>
             <p14:sldId id="292"/>
           </p14:sldIdLst>
         </p14:section>
-        <p14:section name="Extensibility" id="{3a242597-cbe5-1fef-c031-3c5df00a2b88}">
+        <p14:section name="Extensibility" id="{b8a95394-0988-0da4-6efa-6a5077bf1669}">
           <p14:sldIdLst>
             <p14:sldId id="294"/>
             <p14:sldId id="295"/>
           </p14:sldIdLst>
         </p14:section>
-        <p14:section name="Compatibility" id="{cca12748-f2c0-5a1f-75de-14c55bcdea3d}">
+        <p14:section name="Compatibility" id="{a620a47b-638e-afc2-c455-1a8cec3238a8}">
           <p14:sldIdLst>
             <p14:sldId id="297"/>
             <p14:sldId id="298"/>
           </p14:sldIdLst>
         </p14:section>
-        <p14:section name="Verification" id="{054cc0e7-7524-b3fb-c529-f916a425e563}">
+        <p14:section name="Verification" id="{894c9232-e14d-6a9d-144d-70bd51feb868}">
           <p14:sldIdLst>
             <p14:sldId id="300"/>
             <p14:sldId id="301"/>
           </p14:sldIdLst>
         </p14:section>
-        <p14:section name="Tooling" id="{80888589-7aae-7c4a-9ee2-51c08512f810}">
+        <p14:section name="Tooling" id="{de155bea-ec54-5d11-16ef-138cc1742e6c}">
           <p14:sldIdLst>
             <p14:sldId id="303"/>
             <p14:sldId id="304"/>
@@ -268,7 +268,7 @@
             <p14:sldId id="306"/>
           </p14:sldIdLst>
         </p14:section>
-        <p14:section name="Take-away" id="{c3d76002-1f2c-041e-5dc7-5777c5e29f66}">
+        <p14:section name="Take-away" id="{4b2b844e-1c90-9bc8-dd6e-75aaa6b05c15}">
           <p14:sldIdLst>
             <p14:sldId id="307"/>
             <p14:sldId id="308"/>
@@ -278,7 +278,7 @@
             <p14:sldId id="312"/>
           </p14:sldIdLst>
         </p14:section>
-        <p14:section name="Backup" id="{bb953fca-85d9-388e-1242-a974d2ca89f0}">
+        <p14:section name="Backup" id="{8706f1b1-7175-f942-15c5-9ce4576ad07e}">
           <p14:sldIdLst>
             <p14:sldId id="313"/>
             <p14:sldId id="314"/>
@@ -6095,12 +6095,36 @@
           <a:chExt cx="0" cy="0"/>
         </a:xfrm>
       </p:grpSpPr>
-      <p:sp>
-        <p:nvSpPr>
-          <p:cNvPr id="2" name="Text 0"/>
+      <p:pic>
+        <p:nvPicPr>
+          <p:cNvPr id="2" name="Image 0" descr="/private/tmp/claude-501/-Users-wizard-RustroverProjects-zshrs/2555d359-9a79-4736-9207-869cc21577b1/scratchpad/logo/logo-mark.png">    </p:cNvPr>
+          <p:cNvPicPr>
+            <a:picLocks noChangeAspect="1"/>
+          </p:cNvPicPr>
+          <p:nvPr/>
+        </p:nvPicPr>
+        <p:blipFill>
+          <a:blip r:embed="rId1"/>
+          <a:stretch>
+            <a:fillRect/>
+          </a:stretch>
+        </p:blipFill>
+        <p:spPr>
+          <a:xfrm>
+            <a:off x="11384280" y="411480"/>
+            <a:ext cx="502920" cy="502920"/>
+          </a:xfrm>
+          <a:prstGeom prst="rect">
+            <a:avLst/>
+          </a:prstGeom>
+        </p:spPr>
+      </p:pic>
+      <p:sp>
+        <p:nvSpPr>
+          <p:cNvPr id="3" name="Text 0"/>
           <p:cNvSpPr/>
           <p:nvPr>
-            <p:ph idx="100" type="title" hasCustomPrompt="1"/>
+            <p:ph idx="101" type="title" hasCustomPrompt="1"/>
           </p:nvPr>
         </p:nvSpPr>
         <p:spPr>
@@ -6214,12 +6238,36 @@
           <a:chExt cx="0" cy="0"/>
         </a:xfrm>
       </p:grpSpPr>
-      <p:sp>
-        <p:nvSpPr>
-          <p:cNvPr id="2" name="Text 0"/>
+      <p:pic>
+        <p:nvPicPr>
+          <p:cNvPr id="2" name="Image 0" descr="/private/tmp/claude-501/-Users-wizard-RustroverProjects-zshrs/2555d359-9a79-4736-9207-869cc21577b1/scratchpad/logo/logo-mark.png">    </p:cNvPr>
+          <p:cNvPicPr>
+            <a:picLocks noChangeAspect="1"/>
+          </p:cNvPicPr>
+          <p:nvPr/>
+        </p:nvPicPr>
+        <p:blipFill>
+          <a:blip r:embed="rId1"/>
+          <a:stretch>
+            <a:fillRect/>
+          </a:stretch>
+        </p:blipFill>
+        <p:spPr>
+          <a:xfrm>
+            <a:off x="11384280" y="411480"/>
+            <a:ext cx="502920" cy="502920"/>
+          </a:xfrm>
+          <a:prstGeom prst="rect">
+            <a:avLst/>
+          </a:prstGeom>
+        </p:spPr>
+      </p:pic>
+      <p:sp>
+        <p:nvSpPr>
+          <p:cNvPr id="3" name="Text 0"/>
           <p:cNvSpPr/>
           <p:nvPr>
-            <p:ph idx="100" type="title" hasCustomPrompt="1"/>
+            <p:ph idx="101" type="title" hasCustomPrompt="1"/>
           </p:nvPr>
         </p:nvSpPr>
         <p:spPr>
@@ -6767,12 +6815,36 @@
           </a:p>
         </p:txBody>
       </p:sp>
-      <p:sp>
-        <p:nvSpPr>
-          <p:cNvPr id="6" name="Text 0"/>
+      <p:pic>
+        <p:nvPicPr>
+          <p:cNvPr id="6" name="Image 0" descr="/private/tmp/claude-501/-Users-wizard-RustroverProjects-zshrs/2555d359-9a79-4736-9207-869cc21577b1/scratchpad/logo/logo.png">    </p:cNvPr>
+          <p:cNvPicPr>
+            <a:picLocks noChangeAspect="1"/>
+          </p:cNvPicPr>
+          <p:nvPr/>
+        </p:nvPicPr>
+        <p:blipFill>
+          <a:blip r:embed="rId1"/>
+          <a:stretch>
+            <a:fillRect/>
+          </a:stretch>
+        </p:blipFill>
+        <p:spPr>
+          <a:xfrm>
+            <a:off x="822960" y="320040"/>
+            <a:ext cx="4114800" cy="1234440"/>
+          </a:xfrm>
+          <a:prstGeom prst="rect">
+            <a:avLst/>
+          </a:prstGeom>
+        </p:spPr>
+      </p:pic>
+      <p:sp>
+        <p:nvSpPr>
+          <p:cNvPr id="7" name="Text 0"/>
           <p:cNvSpPr/>
           <p:nvPr>
-            <p:ph idx="100" type="title" hasCustomPrompt="1"/>
+            <p:ph idx="101" type="title" hasCustomPrompt="1"/>
           </p:nvPr>
         </p:nvSpPr>
         <p:spPr>
@@ -6875,7 +6947,7 @@
           <p:cNvPr id="2" name="Text 0"/>
           <p:cNvSpPr/>
           <p:nvPr>
-            <p:ph idx="100" type="title" hasCustomPrompt="1"/>
+            <p:ph idx="101" type="title" hasCustomPrompt="1"/>
           </p:nvPr>
         </p:nvSpPr>
         <p:spPr>
@@ -7190,7 +7262,7 @@
           <p:cNvPr id="2" name="Text 0"/>
           <p:cNvSpPr/>
           <p:nvPr>
-            <p:ph idx="100" type="title" hasCustomPrompt="1"/>
+            <p:ph idx="101" type="title" hasCustomPrompt="1"/>
           </p:nvPr>
         </p:nvSpPr>
         <p:spPr>
@@ -8555,7 +8627,7 @@
           <p:cNvPr id="2" name="Text 0"/>
           <p:cNvSpPr/>
           <p:nvPr>
-            <p:ph idx="100" type="title" hasCustomPrompt="1"/>
+            <p:ph idx="101" type="title" hasCustomPrompt="1"/>
           </p:nvPr>
         </p:nvSpPr>
         <p:spPr>
@@ -8916,7 +8988,7 @@
           <p:cNvPr id="2" name="Text 0"/>
           <p:cNvSpPr/>
           <p:nvPr>
-            <p:ph idx="100" type="title" hasCustomPrompt="1"/>
+            <p:ph idx="101" type="title" hasCustomPrompt="1"/>
           </p:nvPr>
         </p:nvSpPr>
         <p:spPr>
@@ -9277,7 +9349,7 @@
           <p:cNvPr id="2" name="Text 0"/>
           <p:cNvSpPr/>
           <p:nvPr>
-            <p:ph idx="100" type="title" hasCustomPrompt="1"/>
+            <p:ph idx="101" type="title" hasCustomPrompt="1"/>
           </p:nvPr>
         </p:nvSpPr>
         <p:spPr>
@@ -9709,7 +9781,7 @@
           <p:cNvPr id="2" name="Text 0"/>
           <p:cNvSpPr/>
           <p:nvPr>
-            <p:ph idx="100" type="title" hasCustomPrompt="1"/>
+            <p:ph idx="101" type="title" hasCustomPrompt="1"/>
           </p:nvPr>
         </p:nvSpPr>
         <p:spPr>
@@ -10121,7 +10193,7 @@
           <p:cNvPr id="2" name="Text 0"/>
           <p:cNvSpPr/>
           <p:nvPr>
-            <p:ph idx="100" type="title" hasCustomPrompt="1"/>
+            <p:ph idx="101" type="title" hasCustomPrompt="1"/>
           </p:nvPr>
         </p:nvSpPr>
         <p:spPr>
@@ -10464,7 +10536,7 @@
           <p:cNvPr id="2" name="Text 0"/>
           <p:cNvSpPr/>
           <p:nvPr>
-            <p:ph idx="100" type="title" hasCustomPrompt="1"/>
+            <p:ph idx="101" type="title" hasCustomPrompt="1"/>
           </p:nvPr>
         </p:nvSpPr>
         <p:spPr>
@@ -10898,7 +10970,7 @@
           <p:cNvPr id="2" name="Text 0"/>
           <p:cNvSpPr/>
           <p:nvPr>
-            <p:ph idx="100" type="title" hasCustomPrompt="1"/>
+            <p:ph idx="101" type="title" hasCustomPrompt="1"/>
           </p:nvPr>
         </p:nvSpPr>
         <p:spPr>
@@ -12263,7 +12335,7 @@
           <p:cNvPr id="2" name="Text 0"/>
           <p:cNvSpPr/>
           <p:nvPr>
-            <p:ph idx="100" type="title" hasCustomPrompt="1"/>
+            <p:ph idx="101" type="title" hasCustomPrompt="1"/>
           </p:nvPr>
         </p:nvSpPr>
         <p:spPr>
@@ -12606,7 +12678,7 @@
           <p:cNvPr id="2" name="Text 0"/>
           <p:cNvSpPr/>
           <p:nvPr>
-            <p:ph idx="100" type="title" hasCustomPrompt="1"/>
+            <p:ph idx="101" type="title" hasCustomPrompt="1"/>
           </p:nvPr>
         </p:nvSpPr>
         <p:spPr>
@@ -13252,7 +13324,7 @@
           <p:cNvPr id="2" name="Text 0"/>
           <p:cNvSpPr/>
           <p:nvPr>
-            <p:ph idx="100" type="title" hasCustomPrompt="1"/>
+            <p:ph idx="101" type="title" hasCustomPrompt="1"/>
           </p:nvPr>
         </p:nvSpPr>
         <p:spPr>
@@ -13595,7 +13667,7 @@
           <p:cNvPr id="2" name="Text 0"/>
           <p:cNvSpPr/>
           <p:nvPr>
-            <p:ph idx="100" type="title" hasCustomPrompt="1"/>
+            <p:ph idx="101" type="title" hasCustomPrompt="1"/>
           </p:nvPr>
         </p:nvSpPr>
         <p:spPr>
@@ -14047,7 +14119,7 @@
           <p:cNvPr id="2" name="Text 0"/>
           <p:cNvSpPr/>
           <p:nvPr>
-            <p:ph idx="100" type="title" hasCustomPrompt="1"/>
+            <p:ph idx="101" type="title" hasCustomPrompt="1"/>
           </p:nvPr>
         </p:nvSpPr>
         <p:spPr>
@@ -14408,7 +14480,7 @@
           <p:cNvPr id="2" name="Text 0"/>
           <p:cNvSpPr/>
           <p:nvPr>
-            <p:ph idx="100" type="title" hasCustomPrompt="1"/>
+            <p:ph idx="101" type="title" hasCustomPrompt="1"/>
           </p:nvPr>
         </p:nvSpPr>
         <p:spPr>
@@ -14751,7 +14823,7 @@
           <p:cNvPr id="2" name="Text 0"/>
           <p:cNvSpPr/>
           <p:nvPr>
-            <p:ph idx="100" type="title" hasCustomPrompt="1"/>
+            <p:ph idx="101" type="title" hasCustomPrompt="1"/>
           </p:nvPr>
         </p:nvSpPr>
         <p:spPr>
@@ -16116,7 +16188,7 @@
           <p:cNvPr id="2" name="Text 0"/>
           <p:cNvSpPr/>
           <p:nvPr>
-            <p:ph idx="100" type="title" hasCustomPrompt="1"/>
+            <p:ph idx="101" type="title" hasCustomPrompt="1"/>
           </p:nvPr>
         </p:nvSpPr>
         <p:spPr>
@@ -16595,7 +16667,7 @@
           <p:cNvPr id="2" name="Text 0"/>
           <p:cNvSpPr/>
           <p:nvPr>
-            <p:ph idx="100" type="title" hasCustomPrompt="1"/>
+            <p:ph idx="101" type="title" hasCustomPrompt="1"/>
           </p:nvPr>
         </p:nvSpPr>
         <p:spPr>
@@ -17153,7 +17225,7 @@
           <p:cNvPr id="2" name="Text 0"/>
           <p:cNvSpPr/>
           <p:nvPr>
-            <p:ph idx="100" type="title" hasCustomPrompt="1"/>
+            <p:ph idx="101" type="title" hasCustomPrompt="1"/>
           </p:nvPr>
         </p:nvSpPr>
         <p:spPr>
@@ -17747,7 +17819,7 @@
           <p:cNvPr id="2" name="Text 0"/>
           <p:cNvSpPr/>
           <p:nvPr>
-            <p:ph idx="100" type="title" hasCustomPrompt="1"/>
+            <p:ph idx="101" type="title" hasCustomPrompt="1"/>
           </p:nvPr>
         </p:nvSpPr>
         <p:spPr>
@@ -18635,7 +18707,7 @@
           <p:cNvPr id="2" name="Text 0"/>
           <p:cNvSpPr/>
           <p:nvPr>
-            <p:ph idx="100" type="title" hasCustomPrompt="1"/>
+            <p:ph idx="101" type="title" hasCustomPrompt="1"/>
           </p:nvPr>
         </p:nvSpPr>
         <p:spPr>
@@ -19047,7 +19119,7 @@
           <p:cNvPr id="2" name="Text 0"/>
           <p:cNvSpPr/>
           <p:nvPr>
-            <p:ph idx="100" type="title" hasCustomPrompt="1"/>
+            <p:ph idx="101" type="title" hasCustomPrompt="1"/>
           </p:nvPr>
         </p:nvSpPr>
         <p:spPr>
@@ -19392,7 +19464,7 @@
           <p:cNvPr id="2" name="Text 0"/>
           <p:cNvSpPr/>
           <p:nvPr>
-            <p:ph idx="100" type="title" hasCustomPrompt="1"/>
+            <p:ph idx="101" type="title" hasCustomPrompt="1"/>
           </p:nvPr>
         </p:nvSpPr>
         <p:spPr>
@@ -19822,7 +19894,7 @@
           <p:cNvPr id="2" name="Text 0"/>
           <p:cNvSpPr/>
           <p:nvPr>
-            <p:ph idx="100" type="title" hasCustomPrompt="1"/>
+            <p:ph idx="101" type="title" hasCustomPrompt="1"/>
           </p:nvPr>
         </p:nvSpPr>
         <p:spPr>
@@ -21187,7 +21259,7 @@
           <p:cNvPr id="2" name="Text 0"/>
           <p:cNvSpPr/>
           <p:nvPr>
-            <p:ph idx="100" type="title" hasCustomPrompt="1"/>
+            <p:ph idx="101" type="title" hasCustomPrompt="1"/>
           </p:nvPr>
         </p:nvSpPr>
         <p:spPr>
@@ -21548,7 +21620,7 @@
           <p:cNvPr id="2" name="Text 0"/>
           <p:cNvSpPr/>
           <p:nvPr>
-            <p:ph idx="100" type="title" hasCustomPrompt="1"/>
+            <p:ph idx="101" type="title" hasCustomPrompt="1"/>
           </p:nvPr>
         </p:nvSpPr>
         <p:spPr>
@@ -21980,7 +22052,7 @@
           <p:cNvPr id="2" name="Text 0"/>
           <p:cNvSpPr/>
           <p:nvPr>
-            <p:ph idx="100" type="title" hasCustomPrompt="1"/>
+            <p:ph idx="101" type="title" hasCustomPrompt="1"/>
           </p:nvPr>
         </p:nvSpPr>
         <p:spPr>
@@ -22394,7 +22466,7 @@
           <p:cNvPr id="2" name="Text 0"/>
           <p:cNvSpPr/>
           <p:nvPr>
-            <p:ph idx="100" type="title" hasCustomPrompt="1"/>
+            <p:ph idx="101" type="title" hasCustomPrompt="1"/>
           </p:nvPr>
         </p:nvSpPr>
         <p:spPr>
@@ -23759,7 +23831,7 @@
           <p:cNvPr id="2" name="Text 0"/>
           <p:cNvSpPr/>
           <p:nvPr>
-            <p:ph idx="100" type="title" hasCustomPrompt="1"/>
+            <p:ph idx="101" type="title" hasCustomPrompt="1"/>
           </p:nvPr>
         </p:nvSpPr>
         <p:spPr>
@@ -24102,7 +24174,7 @@
           <p:cNvPr id="2" name="Text 0"/>
           <p:cNvSpPr/>
           <p:nvPr>
-            <p:ph idx="100" type="title" hasCustomPrompt="1"/>
+            <p:ph idx="101" type="title" hasCustomPrompt="1"/>
           </p:nvPr>
         </p:nvSpPr>
         <p:spPr>
@@ -24445,7 +24517,7 @@
           <p:cNvPr id="2" name="Text 0"/>
           <p:cNvSpPr/>
           <p:nvPr>
-            <p:ph idx="100" type="title" hasCustomPrompt="1"/>
+            <p:ph idx="101" type="title" hasCustomPrompt="1"/>
           </p:nvPr>
         </p:nvSpPr>
         <p:spPr>
@@ -25810,7 +25882,7 @@
           <p:cNvPr id="2" name="Text 0"/>
           <p:cNvSpPr/>
           <p:nvPr>
-            <p:ph idx="100" type="title" hasCustomPrompt="1"/>
+            <p:ph idx="101" type="title" hasCustomPrompt="1"/>
           </p:nvPr>
         </p:nvSpPr>
         <p:spPr>
@@ -26262,7 +26334,7 @@
           <p:cNvPr id="2" name="Text 0"/>
           <p:cNvSpPr/>
           <p:nvPr>
-            <p:ph idx="100" type="title" hasCustomPrompt="1"/>
+            <p:ph idx="101" type="title" hasCustomPrompt="1"/>
           </p:nvPr>
         </p:nvSpPr>
         <p:spPr>
@@ -26754,7 +26826,7 @@
           <p:cNvPr id="2" name="Text 0"/>
           <p:cNvSpPr/>
           <p:nvPr>
-            <p:ph idx="100" type="title" hasCustomPrompt="1"/>
+            <p:ph idx="101" type="title" hasCustomPrompt="1"/>
           </p:nvPr>
         </p:nvSpPr>
         <p:spPr>
@@ -27115,7 +27187,7 @@
           <p:cNvPr id="2" name="Text 0"/>
           <p:cNvSpPr/>
           <p:nvPr>
-            <p:ph idx="100" type="title" hasCustomPrompt="1"/>
+            <p:ph idx="101" type="title" hasCustomPrompt="1"/>
           </p:nvPr>
         </p:nvSpPr>
         <p:spPr>
@@ -28480,7 +28552,7 @@
           <p:cNvPr id="2" name="Text 0"/>
           <p:cNvSpPr/>
           <p:nvPr>
-            <p:ph idx="100" type="title" hasCustomPrompt="1"/>
+            <p:ph idx="101" type="title" hasCustomPrompt="1"/>
           </p:nvPr>
         </p:nvSpPr>
         <p:spPr>
@@ -28841,7 +28913,7 @@
           <p:cNvPr id="2" name="Text 0"/>
           <p:cNvSpPr/>
           <p:nvPr>
-            <p:ph idx="100" type="title" hasCustomPrompt="1"/>
+            <p:ph idx="101" type="title" hasCustomPrompt="1"/>
           </p:nvPr>
         </p:nvSpPr>
         <p:spPr>
@@ -29202,7 +29274,7 @@
           <p:cNvPr id="2" name="Text 0"/>
           <p:cNvSpPr/>
           <p:nvPr>
-            <p:ph idx="100" type="title" hasCustomPrompt="1"/>
+            <p:ph idx="101" type="title" hasCustomPrompt="1"/>
           </p:nvPr>
         </p:nvSpPr>
         <p:spPr>
@@ -30567,7 +30639,7 @@
           <p:cNvPr id="2" name="Text 0"/>
           <p:cNvSpPr/>
           <p:nvPr>
-            <p:ph idx="100" type="title" hasCustomPrompt="1"/>
+            <p:ph idx="101" type="title" hasCustomPrompt="1"/>
           </p:nvPr>
         </p:nvSpPr>
         <p:spPr>
@@ -30910,7 +30982,7 @@
           <p:cNvPr id="2" name="Text 0"/>
           <p:cNvSpPr/>
           <p:nvPr>
-            <p:ph idx="100" type="title" hasCustomPrompt="1"/>
+            <p:ph idx="101" type="title" hasCustomPrompt="1"/>
           </p:nvPr>
         </p:nvSpPr>
         <p:spPr>
@@ -31287,7 +31359,7 @@
           <p:cNvPr id="2" name="Text 0"/>
           <p:cNvSpPr/>
           <p:nvPr>
-            <p:ph idx="100" type="title" hasCustomPrompt="1"/>
+            <p:ph idx="101" type="title" hasCustomPrompt="1"/>
           </p:nvPr>
         </p:nvSpPr>
         <p:spPr>
@@ -32652,7 +32724,7 @@
           <p:cNvPr id="2" name="Text 0"/>
           <p:cNvSpPr/>
           <p:nvPr>
-            <p:ph idx="100" type="title" hasCustomPrompt="1"/>
+            <p:ph idx="101" type="title" hasCustomPrompt="1"/>
           </p:nvPr>
         </p:nvSpPr>
         <p:spPr>
@@ -33046,7 +33118,7 @@
           <p:cNvPr id="2" name="Text 0"/>
           <p:cNvSpPr/>
           <p:nvPr>
-            <p:ph idx="100" type="title" hasCustomPrompt="1"/>
+            <p:ph idx="101" type="title" hasCustomPrompt="1"/>
           </p:nvPr>
         </p:nvSpPr>
         <p:spPr>
@@ -33389,7 +33461,7 @@
           <p:cNvPr id="2" name="Text 0"/>
           <p:cNvSpPr/>
           <p:nvPr>
-            <p:ph idx="100" type="title" hasCustomPrompt="1"/>
+            <p:ph idx="101" type="title" hasCustomPrompt="1"/>
           </p:nvPr>
         </p:nvSpPr>
         <p:spPr>
@@ -34251,7 +34323,7 @@
           <p:cNvPr id="2" name="Text 0"/>
           <p:cNvSpPr/>
           <p:nvPr>
-            <p:ph idx="100" type="title" hasCustomPrompt="1"/>
+            <p:ph idx="101" type="title" hasCustomPrompt="1"/>
           </p:nvPr>
         </p:nvSpPr>
         <p:spPr>
@@ -34703,7 +34775,7 @@
           <p:cNvPr id="2" name="Text 0"/>
           <p:cNvSpPr/>
           <p:nvPr>
-            <p:ph idx="100" type="title" hasCustomPrompt="1"/>
+            <p:ph idx="101" type="title" hasCustomPrompt="1"/>
           </p:nvPr>
         </p:nvSpPr>
         <p:spPr>
@@ -35046,7 +35118,7 @@
           <p:cNvPr id="2" name="Text 0"/>
           <p:cNvSpPr/>
           <p:nvPr>
-            <p:ph idx="100" type="title" hasCustomPrompt="1"/>
+            <p:ph idx="101" type="title" hasCustomPrompt="1"/>
           </p:nvPr>
         </p:nvSpPr>
         <p:spPr>
@@ -35383,7 +35455,7 @@
           <p:cNvPr id="2" name="Text 0"/>
           <p:cNvSpPr/>
           <p:nvPr>
-            <p:ph idx="100" type="title" hasCustomPrompt="1"/>
+            <p:ph idx="101" type="title" hasCustomPrompt="1"/>
           </p:nvPr>
         </p:nvSpPr>
         <p:spPr>
@@ -35720,7 +35792,7 @@
           <p:cNvPr id="2" name="Text 0"/>
           <p:cNvSpPr/>
           <p:nvPr>
-            <p:ph idx="100" type="title" hasCustomPrompt="1"/>
+            <p:ph idx="101" type="title" hasCustomPrompt="1"/>
           </p:nvPr>
         </p:nvSpPr>
         <p:spPr>
@@ -36059,7 +36131,7 @@
           <p:cNvPr id="2" name="Text 0"/>
           <p:cNvSpPr/>
           <p:nvPr>
-            <p:ph idx="100" type="title" hasCustomPrompt="1"/>
+            <p:ph idx="101" type="title" hasCustomPrompt="1"/>
           </p:nvPr>
         </p:nvSpPr>
         <p:spPr>
@@ -36704,7 +36776,7 @@
           <p:cNvPr id="2" name="Text 0"/>
           <p:cNvSpPr/>
           <p:nvPr>
-            <p:ph idx="100" type="title" hasCustomPrompt="1"/>
+            <p:ph idx="101" type="title" hasCustomPrompt="1"/>
           </p:nvPr>
         </p:nvSpPr>
         <p:spPr>
@@ -37077,7 +37149,7 @@
           <p:cNvPr id="5" name="Text 0"/>
           <p:cNvSpPr/>
           <p:nvPr>
-            <p:ph idx="100" type="title" hasCustomPrompt="1"/>
+            <p:ph idx="101" type="title" hasCustomPrompt="1"/>
           </p:nvPr>
         </p:nvSpPr>
         <p:spPr>
@@ -37180,7 +37252,7 @@
           <p:cNvPr id="2" name="Text 0"/>
           <p:cNvSpPr/>
           <p:nvPr>
-            <p:ph idx="100" type="title" hasCustomPrompt="1"/>
+            <p:ph idx="101" type="title" hasCustomPrompt="1"/>
           </p:nvPr>
         </p:nvSpPr>
         <p:spPr>
@@ -37950,7 +38022,7 @@
           <p:cNvPr id="2" name="Text 0"/>
           <p:cNvSpPr/>
           <p:nvPr>
-            <p:ph idx="100" type="title" hasCustomPrompt="1"/>
+            <p:ph idx="101" type="title" hasCustomPrompt="1"/>
           </p:nvPr>
         </p:nvSpPr>
         <p:spPr>
@@ -38384,7 +38456,7 @@
           <p:cNvPr id="2" name="Text 0"/>
           <p:cNvSpPr/>
           <p:nvPr>
-            <p:ph idx="100" type="title" hasCustomPrompt="1"/>
+            <p:ph idx="101" type="title" hasCustomPrompt="1"/>
           </p:nvPr>
         </p:nvSpPr>
         <p:spPr>
@@ -39029,7 +39101,7 @@
           <p:cNvPr id="2" name="Text 0"/>
           <p:cNvSpPr/>
           <p:nvPr>
-            <p:ph idx="100" type="title" hasCustomPrompt="1"/>
+            <p:ph idx="101" type="title" hasCustomPrompt="1"/>
           </p:nvPr>
         </p:nvSpPr>
         <p:spPr>
@@ -40266,7 +40338,7 @@
           <p:cNvPr id="2" name="Text 0"/>
           <p:cNvSpPr/>
           <p:nvPr>
-            <p:ph idx="100" type="title" hasCustomPrompt="1"/>
+            <p:ph idx="101" type="title" hasCustomPrompt="1"/>
           </p:nvPr>
         </p:nvSpPr>
         <p:spPr>
@@ -40848,7 +40920,7 @@
           <p:cNvPr id="2" name="Text 0"/>
           <p:cNvSpPr/>
           <p:nvPr>
-            <p:ph idx="100" type="title" hasCustomPrompt="1"/>
+            <p:ph idx="101" type="title" hasCustomPrompt="1"/>
           </p:nvPr>
         </p:nvSpPr>
         <p:spPr>

</xml_diff>